<commit_message>
M-09: cite the press release retelling, mark the primary source unverified, rebuild the deck
</commit_message>
<xml_diff>
--- a/Mandat_VTB.pptx
+++ b/Mandat_VTB.pptx
@@ -133,7 +133,7 @@
   <p:extLst>
     <p:ext uri="{521415D9-36F7-43E2-AB2F-B90AF26B5E84}">
       <p14:sectionLst xmlns:p14="http://schemas.microsoft.com/office/powerpoint/2010/main">
-        <p14:section name="Питч · 5 минут" id="{42bae044-a584-5d99-1150-1916476af08d}">
+        <p14:section name="Питч · 5 минут" id="{d1c3bb42-218e-f111-ed0f-c5e5a2436fd5}">
           <p14:sldIdLst>
             <p14:sldId id="256"/>
             <p14:sldId id="257"/>
@@ -151,7 +151,7 @@
             <p14:sldId id="269"/>
           </p14:sldIdLst>
         </p14:section>
-        <p14:section name="Приложение для вопросов жюри" id="{915f319b-a27a-5ca8-bd48-0efbac920bde}">
+        <p14:section name="Приложение для вопросов жюри" id="{31ed96b4-6521-7f77-ee4a-352d8d4fc437}">
           <p14:sldIdLst>
             <p14:sldId id="270"/>
             <p14:sldId id="271"/>
@@ -5947,7 +5947,7 @@
                   <a:schemeClr val="bg1"/>
                 </a:solidFill>
               </a:rPr>
-              <a:t>корпоративных клиентов ВТБ (МСФО за 1П 2026) — у каждого есть подписанты и представители, которые меняются</a:t>
+              <a:t>предприятий и предпринимателей у ВТБ (по пресс-релизу к МСФО за 1П 2026) — у каждого есть подписанты и представители, которые меняются</a:t>
             </a:r>
             <a:endParaRPr lang="en-US" sz="1500" dirty="0"/>
           </a:p>
@@ -33473,7 +33473,7 @@
                   <a:schemeClr val="accent4"/>
                 </a:solidFill>
               </a:rPr>
-              <a:t>Источники: ВТБ, МСФО за 1П 2026 (≈1,8 млн корпоративных клиентов; altapress.ru, 29.07.2026); Банк России, I кв. 2026. Доли и минуты — допущения команды; расчёт: python scripts/effect_model.py --scenarios</a:t>
+              <a:t>Источники: ВТБ, МСФО за 1П 2026 (≈1,8 млн предприятий и предпринимателей; пересказ пресс-релиза, altapress.ru, 29.07.2026; первичный источник не открыт); Банк России, I кв. 2026. Доли и минуты — допущения команды; расчёт: python scripts/effect_model.py --scenarios</a:t>
             </a:r>
             <a:endParaRPr lang="en-US" sz="1000" dirty="0"/>
           </a:p>
@@ -33559,7 +33559,7 @@
                   <a:schemeClr val="accent4"/>
                 </a:solidFill>
               </a:rPr>
-              <a:t>≈1,8 млн корпоративных клиентов × доля с событием представительства (10 / 15 / 25%) × сэкономленные минуты на кейс, включая разбор (20 / 30 / 40) ÷ 60 ÷ 1 800 ч на ставку</a:t>
+              <a:t>≈1,8 млн предприятий и ИП × доля с событием представительства (10 / 15 / 25%) × сэкономленные минуты на кейс, включая разбор (20 / 30 / 40) ÷ 60 ÷ 1 800 ч на ставку</a:t>
             </a:r>
             <a:endParaRPr lang="en-US" sz="1300" dirty="0"/>
           </a:p>

</xml_diff>

<commit_message>
Deck: slide 5 verdicts from evidence.json, 0.3.0 scope and the confirmed question
</commit_message>
<xml_diff>
--- a/Mandat_VTB.pptx
+++ b/Mandat_VTB.pptx
@@ -133,7 +133,7 @@
   <p:extLst>
     <p:ext uri="{521415D9-36F7-43E2-AB2F-B90AF26B5E84}">
       <p14:sectionLst xmlns:p14="http://schemas.microsoft.com/office/powerpoint/2010/main">
-        <p14:section name="Питч · 5 минут" id="{d1c3bb42-218e-f111-ed0f-c5e5a2436fd5}">
+        <p14:section name="Питч · 5 минут" id="{41e23d32-2cca-63e5-00fa-5c5ae68e3539}">
           <p14:sldIdLst>
             <p14:sldId id="256"/>
             <p14:sldId id="257"/>
@@ -151,7 +151,7 @@
             <p14:sldId id="269"/>
           </p14:sldIdLst>
         </p14:section>
-        <p14:section name="Приложение для вопросов жюри" id="{31ed96b4-6521-7f77-ee4a-352d8d4fc437}">
+        <p14:section name="Приложение для вопросов жюри" id="{491995d3-1f64-2e2c-832c-cc773ac3cca3}">
           <p14:sldIdLst>
             <p14:sldId id="270"/>
             <p14:sldId id="271"/>
@@ -3328,7 +3328,7 @@
           <a:p>
             <a:r>
               <a:rPr lang="en-US" dirty="0"/>
-              <a:t>[1:30–2:05] Так выглядит вердикт. Директор, выдавший доверенность, сменился полгода назад, но доверенность не отменена — по ГК она действует. «Мандат» подтверждает и ставит сигнал, а не отказывает. Каждая строка — с доказательством: ГРН записи ЕГРЮЛ, путь до поля МЧД, норма. Та же компания, но директор сменился 19 дней назад, — на разбор с приоритетом P1 и сроком четыре часа. А если отменили основную доверенность, передоверие теряет силу — опровергнуто.</a:t>
+              <a:t>[1:30–2:05] Так выглядит вердикт. Директор, выдавший доверенность, сменился полгода назад, но доверенность не отменена — по ГК она действует. Когда юрист отметил, что устав операцию не ограничивает, «Мандат» подтверждает и ставит сигнал, а не отказывает; в демо эта отметка синтетическая, без неё тот же кейс уходит на разбор. Каждая строка — с доказательством: ГРН записи ЕГРЮЛ, путь до поля МЧД, норма. Та же компания, но директор сменился 19 дней назад, — на разбор с приоритетом P1 и сроком четыре часа. А если отменили основную доверенность, передоверие теряет силу — опровергнуто.</a:t>
             </a:r>
             <a:endParaRPr lang="en-US" dirty="0"/>
           </a:p>
@@ -6093,7 +6093,7 @@
                   <a:schemeClr val="accent4"/>
                 </a:solidFill>
               </a:rPr>
-              <a:t>Источники: vtb.ru — «Комплект МЧД и КЭП» в «ВТБ Бизнес», 10.2026; репозиторий «Мандата» v0.3.0: 312 автотестов, evidence.json от 13.10.2026</a:t>
+              <a:t>Источники: vtb.ru — «Комплект МЧД и КЭП» в «ВТБ Бизнес», 10.2026; репозиторий «Мандата» v0.3.0: 322 автотеста, evidence.json от 13.10.2026</a:t>
             </a:r>
             <a:endParaRPr lang="en-US" sz="1000" dirty="0"/>
           </a:p>
@@ -6920,7 +6920,7 @@
                   <a:schemeClr val="bg1"/>
                 </a:solidFill>
               </a:rPr>
-              <a:t>36 правил, 13 демо-кейсов, CLI и HTTP API</a:t>
+              <a:t>36 правил, 14 демо-кейсов, CLI и HTTP API</a:t>
             </a:r>
             <a:endParaRPr lang="en-US" sz="1500" dirty="0"/>
           </a:p>
@@ -6956,7 +6956,7 @@
                   <a:schemeClr val="bg1"/>
                 </a:solidFill>
               </a:rPr>
-              <a:t>312 автотестов проходят, каждое число воспроизводится командой</a:t>
+              <a:t>322 автотеста проходят, каждое число воспроизводится командой</a:t>
             </a:r>
             <a:endParaRPr lang="en-US" sz="1500" dirty="0"/>
           </a:p>
@@ -22356,7 +22356,7 @@
                           <a:ea typeface="Calibri" pitchFamily="34" charset="-122"/>
                           <a:cs typeface="Calibri" pitchFamily="34" charset="-120"/>
                         </a:rPr>
-                        <a:t>Ядро, 36 правил, журнал, мониторинг, удостоверения. Заглушки — источники данных; каждый отчёт сам это показывает</a:t>
+                        <a:t>Ядро, 36 правил, журнал, мониторинг (Standard Webhooks), роли API, SBOM. Заглушки — реестр ФНС, ЕФРСБ, КЭП</a:t>
                       </a:r>
                       <a:endParaRPr lang="en-US" sz="1300" dirty="0">
                         <a:latin typeface="Calibri" charset="0"/>
@@ -22426,7 +22426,7 @@
                           <a:ea typeface="Calibri" pitchFamily="34" charset="-122"/>
                           <a:cs typeface="Calibri" pitchFamily="34" charset="-120"/>
                         </a:rPr>
-                        <a:t>Сколько «на разбор» получат сотрудники?</a:t>
+                        <a:t>Почему почти нет «подтверждено»?</a:t>
                       </a:r>
                       <a:endParaRPr lang="en-US" sz="1300" dirty="0">
                         <a:latin typeface="Calibri" charset="0"/>
@@ -22494,7 +22494,7 @@
                           <a:ea typeface="Calibri" pitchFamily="34" charset="-122"/>
                           <a:cs typeface="Calibri" pitchFamily="34" charset="-120"/>
                         </a:rPr>
-                        <a:t>На корпусе 61%, на реальном потоке — вторая метрика пилота с порогом банка</a:t>
+                        <a:t>«Да» — только если закрыт и устав; без разметки устава 61% корпуса уходит человеку</a:t>
                       </a:r>
                       <a:endParaRPr lang="en-US" sz="1300" dirty="0">
                         <a:latin typeface="Calibri" charset="0"/>
@@ -23636,7 +23636,7 @@
                           <a:ea typeface="Calibri" pitchFamily="34" charset="-122"/>
                           <a:cs typeface="Calibri" pitchFamily="34" charset="-120"/>
                         </a:rPr>
-                        <a:t>312 автотестов проходят (v0.3.0, evidence.json), независимая проверка на Cedar, реестр утверждений: каждое число воспроизводится командой</a:t>
+                        <a:t>322 автотеста проходят (v0.3.0, evidence.json), независимая проверка на Cedar, реестр утверждений: каждое число воспроизводится командой</a:t>
                       </a:r>
                       <a:endParaRPr lang="en-US" sz="1300" dirty="0">
                         <a:latin typeface="Calibri" charset="0"/>
@@ -29255,7 +29255,7 @@
                   <a:schemeClr val="accent4"/>
                 </a:solidFill>
               </a:rPr>
-              <a:t>Демо-кейсы 10, 05 и 11 из репозитория «Мандата»; данные вымышлены. Реестр МЧД и проверка КЭП в стенде — заглушки, это видно в каждом отчёте</a:t>
+              <a:t>Демо-кейсы 14, 05 и 11 из репозитория «Мандата»; данные вымышлены, отметка юриста об уставе в кейсе 14 синтетическая. Реестр МЧД и проверка КЭП в стенде — заглушки, это видно в каждом отчёте</a:t>
             </a:r>
             <a:endParaRPr lang="en-US" sz="1000" dirty="0"/>
           </a:p>
@@ -29325,7 +29325,7 @@
                   <a:schemeClr val="tx2"/>
                 </a:solidFill>
               </a:rPr>
-              <a:t>Кейс 10 · ООО «Ясная поляна» · синтетические данные</a:t>
+              <a:t>Кейс 14 · синтетическая отметка об уставе</a:t>
             </a:r>
             <a:endParaRPr lang="en-US" sz="1300" dirty="0"/>
           </a:p>

</xml_diff>

<commit_message>
Tighten regression tests, state the XSD status, rebuild the deck
- Regression tests expect the specific rejection for fractional amounts
  and revocations without a POA number, and exact API status codes
- test_cedar.py skips when cedarpy is not installed; CI installs it
- AUDIT_CLOSURE M11 and the deck roadmap: EMCHD paths are checked
  against open copies of the XSD, no official FNS publication found
- Deck rebuilt from evidence.json: 39 rules
</commit_message>
<xml_diff>
--- a/Mandat_VTB.pptx
+++ b/Mandat_VTB.pptx
@@ -133,7 +133,7 @@
   <p:extLst>
     <p:ext uri="{521415D9-36F7-43E2-AB2F-B90AF26B5E84}">
       <p14:sectionLst xmlns:p14="http://schemas.microsoft.com/office/powerpoint/2010/main">
-        <p14:section name="Питч · 5 минут" id="{41e23d32-2cca-63e5-00fa-5c5ae68e3539}">
+        <p14:section name="Питч · 5 минут" id="{dafa199d-4ecb-7b22-1ebd-69f42d177d0c}">
           <p14:sldIdLst>
             <p14:sldId id="256"/>
             <p14:sldId id="257"/>
@@ -151,7 +151,7 @@
             <p14:sldId id="269"/>
           </p14:sldIdLst>
         </p14:section>
-        <p14:section name="Приложение для вопросов жюри" id="{491995d3-1f64-2e2c-832c-cc773ac3cca3}">
+        <p14:section name="Приложение для вопросов жюри" id="{e50200b7-bd51-a77a-2e29-236081daeec0}">
           <p14:sldIdLst>
             <p14:sldId id="270"/>
             <p14:sldId id="271"/>
@@ -6093,7 +6093,7 @@
                   <a:schemeClr val="accent4"/>
                 </a:solidFill>
               </a:rPr>
-              <a:t>Источники: vtb.ru — «Комплект МЧД и КЭП» в «ВТБ Бизнес», 10.2026; репозиторий «Мандата» v0.3.0: 322 автотеста, evidence.json от 13.10.2026</a:t>
+              <a:t>Источники: vtb.ru — «Комплект МЧД и КЭП» в «ВТБ Бизнес», 10.2026; репозиторий «Мандата» v0.3.0: 584 автотеста, evidence.json от 13.10.2026</a:t>
             </a:r>
             <a:endParaRPr lang="en-US" sz="1000" dirty="0"/>
           </a:p>
@@ -6525,7 +6525,7 @@
                   <a:schemeClr val="bg1"/>
                 </a:solidFill>
               </a:rPr>
-              <a:t>36 правил с нормой</a:t>
+              <a:t>39 правил с нормой</a:t>
             </a:r>
             <a:endParaRPr lang="en-US" sz="1400" dirty="0"/>
           </a:p>
@@ -6920,7 +6920,7 @@
                   <a:schemeClr val="bg1"/>
                 </a:solidFill>
               </a:rPr>
-              <a:t>36 правил, 14 демо-кейсов, CLI и HTTP API</a:t>
+              <a:t>39 правил, 14 демо-кейсов, CLI и HTTP API</a:t>
             </a:r>
             <a:endParaRPr lang="en-US" sz="1500" dirty="0"/>
           </a:p>
@@ -6956,7 +6956,7 @@
                   <a:schemeClr val="bg1"/>
                 </a:solidFill>
               </a:rPr>
-              <a:t>322 автотеста проходят, каждое число воспроизводится командой</a:t>
+              <a:t>584 автотеста проходят, каждое число воспроизводится командой</a:t>
             </a:r>
             <a:endParaRPr lang="en-US" sz="1500" dirty="0"/>
           </a:p>
@@ -11693,7 +11693,7 @@
                   <a:schemeClr val="bg1"/>
                 </a:solidFill>
               </a:rPr>
-              <a:t>36 правил со ссылкой на норму: что они ловят</a:t>
+              <a:t>39 правил со ссылкой на норму: что они ловят</a:t>
             </a:r>
             <a:endParaRPr lang="en-US" sz="2800" dirty="0"/>
           </a:p>
@@ -21528,7 +21528,7 @@
                           <a:ea typeface="Calibri" pitchFamily="34" charset="-122"/>
                           <a:cs typeface="Calibri" pitchFamily="34" charset="-120"/>
                         </a:rPr>
-                        <a:t>Реестр отвечает «действует или отменена». Мы — покрывает ли МЧД эту операцию у этой компании на эту дату, с ЕГРЮЛ, уставом, передоверием и событиями. Статус реестра — одно из 36 правил</a:t>
+                        <a:t>Реестр отвечает «действует или отменена». Мы — покрывает ли МЧД эту операцию у этой компании на эту дату, с ЕГРЮЛ, уставом, передоверием и событиями. Статус реестра — одно из 39 правил</a:t>
                       </a:r>
                       <a:endParaRPr lang="en-US" sz="1300" dirty="0">
                         <a:latin typeface="Calibri" charset="0"/>
@@ -22356,7 +22356,7 @@
                           <a:ea typeface="Calibri" pitchFamily="34" charset="-122"/>
                           <a:cs typeface="Calibri" pitchFamily="34" charset="-120"/>
                         </a:rPr>
-                        <a:t>Ядро, 36 правил, журнал, мониторинг (Standard Webhooks), роли API, SBOM. Заглушки — реестр ФНС, ЕФРСБ, КЭП</a:t>
+                        <a:t>Ядро, 39 правил, журнал, мониторинг (Standard Webhooks), роли API, SBOM. Заглушки — реестр ФНС, ЕФРСБ, КЭП</a:t>
                       </a:r>
                       <a:endParaRPr lang="en-US" sz="1300" dirty="0">
                         <a:latin typeface="Calibri" charset="0"/>
@@ -23636,7 +23636,7 @@
                           <a:ea typeface="Calibri" pitchFamily="34" charset="-122"/>
                           <a:cs typeface="Calibri" pitchFamily="34" charset="-120"/>
                         </a:rPr>
-                        <a:t>322 автотеста проходят (v0.3.0, evidence.json), независимая проверка на Cedar, реестр утверждений: каждое число воспроизводится командой</a:t>
+                        <a:t>584 автотеста проходят (v0.3.0, evidence.json), независимая проверка на Cedar, реестр утверждений: каждое число воспроизводится командой</a:t>
                       </a:r>
                       <a:endParaRPr lang="en-US" sz="1300" dirty="0">
                         <a:latin typeface="Calibri" charset="0"/>
@@ -25735,7 +25735,7 @@
                   <a:schemeClr val="bg1"/>
                 </a:solidFill>
               </a:rPr>
-              <a:t>сверка формата с официальной XSD</a:t>
+              <a:t>сверка формата с официальной XSD ФНС (пока — с открытыми копиями)</a:t>
             </a:r>
             <a:endParaRPr lang="en-US" sz="1500" dirty="0"/>
           </a:p>
@@ -28965,7 +28965,7 @@
                   <a:schemeClr val="bg1"/>
                 </a:solidFill>
               </a:rPr>
-              <a:t>граф полномочий на дату, 36 правил с нормой</a:t>
+              <a:t>граф полномочий на дату, 39 правил с нормой</a:t>
             </a:r>
             <a:endParaRPr lang="en-US" sz="1400" dirty="0"/>
           </a:p>
@@ -32814,7 +32814,7 @@
                   <a:schemeClr val="bg1"/>
                 </a:solidFill>
               </a:rPr>
-              <a:t>36 правил с нормой</a:t>
+              <a:t>39 правил с нормой</a:t>
             </a:r>
             <a:endParaRPr lang="en-US" sz="1500" dirty="0"/>
           </a:p>

</xml_diff>

<commit_message>
Publish key files atomically, run the namespace rejection test on mutants, record the rebuilt deck
- Key files are written to a 0600 temporary file in the same directory,
  synced, and published with a hard link, so readers never see a partial
  key and an existing key is never replaced; a failed write leaves nothing
- The namespace mutation control runs the same rejection check against
  each mutant and expects it to fail
- evidence.json and the deck rebuilt (585 tests); AUDIT_CLOSURE M14 and
  SUBMISSION_DRIFT describe the rebuilt deck
</commit_message>
<xml_diff>
--- a/Mandat_VTB.pptx
+++ b/Mandat_VTB.pptx
@@ -133,7 +133,7 @@
   <p:extLst>
     <p:ext uri="{521415D9-36F7-43E2-AB2F-B90AF26B5E84}">
       <p14:sectionLst xmlns:p14="http://schemas.microsoft.com/office/powerpoint/2010/main">
-        <p14:section name="Питч · 5 минут" id="{dafa199d-4ecb-7b22-1ebd-69f42d177d0c}">
+        <p14:section name="Питч · 5 минут" id="{c676c9ee-fe05-524d-6924-e86738b3036c}">
           <p14:sldIdLst>
             <p14:sldId id="256"/>
             <p14:sldId id="257"/>
@@ -151,7 +151,7 @@
             <p14:sldId id="269"/>
           </p14:sldIdLst>
         </p14:section>
-        <p14:section name="Приложение для вопросов жюри" id="{e50200b7-bd51-a77a-2e29-236081daeec0}">
+        <p14:section name="Приложение для вопросов жюри" id="{b2623680-25d9-8a8e-7c62-e60e33e9473b}">
           <p14:sldIdLst>
             <p14:sldId id="270"/>
             <p14:sldId id="271"/>
@@ -6093,7 +6093,7 @@
                   <a:schemeClr val="accent4"/>
                 </a:solidFill>
               </a:rPr>
-              <a:t>Источники: vtb.ru — «Комплект МЧД и КЭП» в «ВТБ Бизнес», 10.2026; репозиторий «Мандата» v0.3.0: 584 автотеста, evidence.json от 13.10.2026</a:t>
+              <a:t>Источники: vtb.ru — «Комплект МЧД и КЭП» в «ВТБ Бизнес», 10.2026; репозиторий «Мандата» v0.3.0: 585 автотестов, evidence.json от 13.10.2026</a:t>
             </a:r>
             <a:endParaRPr lang="en-US" sz="1000" dirty="0"/>
           </a:p>
@@ -6956,7 +6956,7 @@
                   <a:schemeClr val="bg1"/>
                 </a:solidFill>
               </a:rPr>
-              <a:t>584 автотеста проходят, каждое число воспроизводится командой</a:t>
+              <a:t>585 автотестов проходят, каждое число воспроизводится командой</a:t>
             </a:r>
             <a:endParaRPr lang="en-US" sz="1500" dirty="0"/>
           </a:p>
@@ -23636,7 +23636,7 @@
                           <a:ea typeface="Calibri" pitchFamily="34" charset="-122"/>
                           <a:cs typeface="Calibri" pitchFamily="34" charset="-120"/>
                         </a:rPr>
-                        <a:t>584 автотеста проходят (v0.3.0, evidence.json), независимая проверка на Cedar, реестр утверждений: каждое число воспроизводится командой</a:t>
+                        <a:t>585 автотестов проходят (v0.3.0, evidence.json), независимая проверка на Cedar, реестр утверждений: каждое число воспроизводится командой</a:t>
                       </a:r>
                       <a:endParaRPr lang="en-US" sz="1300" dirty="0">
                         <a:latin typeface="Calibri" charset="0"/>

</xml_diff>

<commit_message>
Deck: precise Fenergo wording on slide 23
</commit_message>
<xml_diff>
--- a/Mandat_VTB.pptx
+++ b/Mandat_VTB.pptx
@@ -133,7 +133,7 @@
   <p:extLst>
     <p:ext uri="{521415D9-36F7-43E2-AB2F-B90AF26B5E84}">
       <p14:sectionLst xmlns:p14="http://schemas.microsoft.com/office/powerpoint/2010/main">
-        <p14:section name="Питч · 5 минут" id="{1B3BA410-F50E-A210-E836-06FDBD208553}">
+        <p14:section name="Питч · 5 минут" id="{DDBDEC19-EA96-DEDF-74E8-F21AF0B0387A}">
           <p14:sldIdLst>
             <p14:sldId id="256"/>
             <p14:sldId id="257"/>
@@ -151,7 +151,7 @@
             <p14:sldId id="269"/>
           </p14:sldIdLst>
         </p14:section>
-        <p14:section name="Приложение для вопросов жюри" id="{DBB4B4C6-0388-8443-0633-9DA419060DFF}">
+        <p14:section name="Приложение для вопросов жюри" id="{B5D09980-A84E-AEC4-9140-3EBAE44C6E77}">
           <p14:sldIdLst>
             <p14:sldId id="270"/>
             <p14:sldId id="271"/>
@@ -199,7 +199,7 @@
               </a:defRPr>
             </a:pPr>
             <a:r>
-              <a:rPr lang="ru-RU" sz="1500" b="0" i="0" u="none" strike="noStrike">
+              <a:rPr sz="1500" b="0" i="0" u="none" strike="noStrike">
                 <a:solidFill>
                   <a:srgbClr val="F3F6F9"/>
                 </a:solidFill>
@@ -246,7 +246,7 @@
             <c:bubble3D val="0"/>
             <c:extLst>
               <c:ext xmlns:c16="http://schemas.microsoft.com/office/drawing/2014/chart" uri="{C3380CC4-5D6E-409C-BE32-E72D297353CC}">
-                <c16:uniqueId val="{00000001-F217-4256-878D-4EF3F2BA4377}"/>
+                <c16:uniqueId val="{00000001-CB2A-431E-BB98-8AE8627E2A35}"/>
               </c:ext>
             </c:extLst>
           </c:dPt>
@@ -262,7 +262,7 @@
             </c:spPr>
             <c:extLst>
               <c:ext xmlns:c16="http://schemas.microsoft.com/office/drawing/2014/chart" uri="{C3380CC4-5D6E-409C-BE32-E72D297353CC}">
-                <c16:uniqueId val="{00000003-F217-4256-878D-4EF3F2BA4377}"/>
+                <c16:uniqueId val="{00000003-CB2A-431E-BB98-8AE8627E2A35}"/>
               </c:ext>
             </c:extLst>
           </c:dPt>
@@ -278,7 +278,7 @@
             </c:spPr>
             <c:extLst>
               <c:ext xmlns:c16="http://schemas.microsoft.com/office/drawing/2014/chart" uri="{C3380CC4-5D6E-409C-BE32-E72D297353CC}">
-                <c16:uniqueId val="{00000005-F217-4256-878D-4EF3F2BA4377}"/>
+                <c16:uniqueId val="{00000005-CB2A-431E-BB98-8AE8627E2A35}"/>
               </c:ext>
             </c:extLst>
           </c:dPt>
@@ -294,7 +294,7 @@
             </c:spPr>
             <c:extLst>
               <c:ext xmlns:c16="http://schemas.microsoft.com/office/drawing/2014/chart" uri="{C3380CC4-5D6E-409C-BE32-E72D297353CC}">
-                <c16:uniqueId val="{00000007-F217-4256-878D-4EF3F2BA4377}"/>
+                <c16:uniqueId val="{00000007-CB2A-431E-BB98-8AE8627E2A35}"/>
               </c:ext>
             </c:extLst>
           </c:dPt>
@@ -378,7 +378,7 @@
           </c:val>
           <c:extLst>
             <c:ext xmlns:c16="http://schemas.microsoft.com/office/drawing/2014/chart" uri="{C3380CC4-5D6E-409C-BE32-E72D297353CC}">
-              <c16:uniqueId val="{00000008-F217-4256-878D-4EF3F2BA4377}"/>
+              <c16:uniqueId val="{00000008-CB2A-431E-BB98-8AE8627E2A35}"/>
             </c:ext>
           </c:extLst>
         </c:ser>
@@ -496,7 +496,7 @@
               </a:defRPr>
             </a:pPr>
             <a:r>
-              <a:rPr lang="ru-RU" sz="1500" b="0" i="0" u="none" strike="noStrike">
+              <a:rPr sz="1500" b="0" i="0" u="none" strike="noStrike">
                 <a:solidFill>
                   <a:srgbClr val="F3F6F9"/>
                 </a:solidFill>
@@ -611,7 +611,7 @@
           </c:val>
           <c:extLst>
             <c:ext xmlns:c16="http://schemas.microsoft.com/office/drawing/2014/chart" uri="{C3380CC4-5D6E-409C-BE32-E72D297353CC}">
-              <c16:uniqueId val="{00000000-9B47-4981-BFD7-90FC8339C0ED}"/>
+              <c16:uniqueId val="{00000000-CF01-4AB3-9AD8-984BF815EB40}"/>
             </c:ext>
           </c:extLst>
         </c:ser>
@@ -730,7 +730,7 @@
               </a:defRPr>
             </a:pPr>
             <a:r>
-              <a:rPr lang="ru-RU" sz="1500" b="0" i="0" u="none" strike="noStrike">
+              <a:rPr sz="1500" b="0" i="0" u="none" strike="noStrike">
                 <a:solidFill>
                   <a:srgbClr val="F3F6F9"/>
                 </a:solidFill>
@@ -845,7 +845,7 @@
           </c:val>
           <c:extLst>
             <c:ext xmlns:c16="http://schemas.microsoft.com/office/drawing/2014/chart" uri="{C3380CC4-5D6E-409C-BE32-E72D297353CC}">
-              <c16:uniqueId val="{00000000-9E17-4B55-8CC7-834AB03D16E4}"/>
+              <c16:uniqueId val="{00000000-9E5F-4A10-A33A-EE3CA865DBDD}"/>
             </c:ext>
           </c:extLst>
         </c:ser>
@@ -967,7 +967,7 @@
     </p:spTree>
     <p:extLst>
       <p:ext uri="{BB962C8B-B14F-4D97-AF65-F5344CB8AC3E}">
-        <p14:creationId xmlns:p14="http://schemas.microsoft.com/office/powerpoint/2010/main" val="3970828819"/>
+        <p14:creationId xmlns:p14="http://schemas.microsoft.com/office/powerpoint/2010/main" val="2623308708"/>
       </p:ext>
     </p:extLst>
   </p:cSld>
@@ -9132,7 +9132,7 @@
         </p:nvGraphicFramePr>
         <p:xfrm>
           <a:off x="548640" y="1325880"/>
-          <a:ext cx="11091672" cy="3621024"/>
+          <a:ext cx="11091672" cy="914400"/>
         </p:xfrm>
         <a:graphic>
           <a:graphicData uri="http://schemas.openxmlformats.org/drawingml/2006/table">
@@ -11497,7 +11497,7 @@
         </p:nvGraphicFramePr>
         <p:xfrm>
           <a:off x="548640" y="1325880"/>
-          <a:ext cx="11091672" cy="4389120"/>
+          <a:ext cx="11091672" cy="914400"/>
         </p:xfrm>
         <a:graphic>
           <a:graphicData uri="http://schemas.openxmlformats.org/drawingml/2006/table">
@@ -19255,7 +19255,7 @@
         </p:nvGraphicFramePr>
         <p:xfrm>
           <a:off x="548640" y="1325880"/>
-          <a:ext cx="11091672" cy="4224528"/>
+          <a:ext cx="11091672" cy="914400"/>
         </p:xfrm>
         <a:graphic>
           <a:graphicData uri="http://schemas.openxmlformats.org/drawingml/2006/table">
@@ -20909,7 +20909,7 @@
                   <a:schemeClr val="accent4"/>
                 </a:solidFill>
               </a:rPr>
-              <a:t>Источники: Банк России, I кв. 2026; ВТБ, МСФО за 1П 2026; Fenergo — опросы банков 2022 и 2025 (данные поставщика ПО)</a:t>
+              <a:t>Источники: Банк России, I кв. 2026; ВТБ, МСФО за 1П 2026; Fenergo — отраслевые опросы 2022 и 2025 гг.</a:t>
             </a:r>
             <a:endParaRPr lang="en-US" sz="1000" dirty="0"/>
           </a:p>
@@ -21183,7 +21183,7 @@
                   <a:schemeClr val="bg1"/>
                 </a:solidFill>
               </a:rPr>
-              <a:t>1 500–3 000 долл. США — стоимость проверки корпоративного клиента у 54% банков (опрос Fenergo, 2022; данные поставщика ПО)</a:t>
+              <a:t>1 500–3 000 долл. США — столько больше половины корпоративных банков тратят на одну KYC-проверку клиента (опрос Fenergo, 2022; данные поставщика ПО)</a:t>
             </a:r>
             <a:endParaRPr lang="en-US" sz="1500" dirty="0"/>
           </a:p>
@@ -21201,7 +21201,7 @@
                   <a:schemeClr val="bg1"/>
                 </a:solidFill>
               </a:rPr>
-              <a:t>70% банков теряли клиентов из-за медленного подключения в 2025 году (опрос Fenergo; данные поставщика ПО)</a:t>
+              <a:t>70% финансовых организаций (банки, управляющие активами, фонд-администраторы; Великобритания, США, Сингапур) за год до опроса теряли клиентов из-за медленного подключения (опрос Fenergo, август 2025; данные поставщика ПО)</a:t>
             </a:r>
             <a:endParaRPr lang="en-US" sz="1500" dirty="0"/>
           </a:p>
@@ -21469,7 +21469,7 @@
         </p:nvGraphicFramePr>
         <p:xfrm>
           <a:off x="548640" y="1325880"/>
-          <a:ext cx="11091672" cy="4937760"/>
+          <a:ext cx="11091672" cy="914400"/>
         </p:xfrm>
         <a:graphic>
           <a:graphicData uri="http://schemas.openxmlformats.org/drawingml/2006/table">
@@ -22948,7 +22948,7 @@
         </p:nvGraphicFramePr>
         <p:xfrm>
           <a:off x="548640" y="1325880"/>
-          <a:ext cx="11091672" cy="4536440"/>
+          <a:ext cx="11091672" cy="914400"/>
         </p:xfrm>
         <a:graphic>
           <a:graphicData uri="http://schemas.openxmlformats.org/drawingml/2006/table">
@@ -24284,7 +24284,7 @@
         </p:nvGraphicFramePr>
         <p:xfrm>
           <a:off x="548640" y="1325880"/>
-          <a:ext cx="11091672" cy="4828032"/>
+          <a:ext cx="11091672" cy="914400"/>
         </p:xfrm>
         <a:graphic>
           <a:graphicData uri="http://schemas.openxmlformats.org/drawingml/2006/table">

</xml_diff>